<commit_message>
Add ASX forward curve to price chart (kit + pack)
Co-Authored-By: Claude Opus 4.8 <noreply@anthropic.com>
</commit_message>
<xml_diff>
--- a/nem-team-day/Reading-the-NEM-Team-Day.pptx
+++ b/nem-team-day/Reading-the-NEM-Team-Day.pptx
@@ -171,9 +171,9 @@
           </c:marker>
           <c:cat>
             <c:strRef>
-              <c:f>Sheet1!$A$2:$A$13</c:f>
+              <c:f>Sheet1!$A$2:$A$15</c:f>
               <c:strCache>
-                <c:ptCount val="12"/>
+                <c:ptCount val="14"/>
                 <c:pt idx="0">
                   <c:v>2015</c:v>
                 </c:pt>
@@ -209,16 +209,22 @@
                 </c:pt>
                 <c:pt idx="11">
                   <c:v>2026</c:v>
+                </c:pt>
+                <c:pt idx="12">
+                  <c:v>CY27f</c:v>
+                </c:pt>
+                <c:pt idx="13">
+                  <c:v>CY28f</c:v>
                 </c:pt>
               </c:strCache>
             </c:strRef>
           </c:cat>
           <c:val>
             <c:numRef>
-              <c:f>Sheet1!$B$2:$B$13</c:f>
+              <c:f>Sheet1!$B$2:$B$15</c:f>
               <c:numCache>
                 <c:formatCode>"$"0</c:formatCode>
-                <c:ptCount val="12"/>
+                <c:ptCount val="14"/>
                 <c:pt idx="0">
                   <c:v>39</c:v>
                 </c:pt>
@@ -254,6 +260,12 @@
                 </c:pt>
                 <c:pt idx="11">
                   <c:v>74</c:v>
+                </c:pt>
+                <c:pt idx="12">
+                  <c:v>85</c:v>
+                </c:pt>
+                <c:pt idx="13">
+                  <c:v>86</c:v>
                 </c:pt>
               </c:numCache>
             </c:numRef>
@@ -286,9 +298,9 @@
           </c:marker>
           <c:cat>
             <c:strRef>
-              <c:f>Sheet1!$A$2:$A$13</c:f>
+              <c:f>Sheet1!$A$2:$A$15</c:f>
               <c:strCache>
-                <c:ptCount val="12"/>
+                <c:ptCount val="14"/>
                 <c:pt idx="0">
                   <c:v>2015</c:v>
                 </c:pt>
@@ -324,16 +336,22 @@
                 </c:pt>
                 <c:pt idx="11">
                   <c:v>2026</c:v>
+                </c:pt>
+                <c:pt idx="12">
+                  <c:v>CY27f</c:v>
+                </c:pt>
+                <c:pt idx="13">
+                  <c:v>CY28f</c:v>
                 </c:pt>
               </c:strCache>
             </c:strRef>
           </c:cat>
           <c:val>
             <c:numRef>
-              <c:f>Sheet1!$C$2:$C$13</c:f>
+              <c:f>Sheet1!$C$2:$C$15</c:f>
               <c:numCache>
                 <c:formatCode>"$"0</c:formatCode>
-                <c:ptCount val="12"/>
+                <c:ptCount val="14"/>
                 <c:pt idx="0">
                   <c:v>52</c:v>
                 </c:pt>
@@ -369,6 +387,12 @@
                 </c:pt>
                 <c:pt idx="11">
                   <c:v>66</c:v>
+                </c:pt>
+                <c:pt idx="12">
+                  <c:v>75</c:v>
+                </c:pt>
+                <c:pt idx="13">
+                  <c:v>74</c:v>
                 </c:pt>
               </c:numCache>
             </c:numRef>
@@ -401,9 +425,9 @@
           </c:marker>
           <c:cat>
             <c:strRef>
-              <c:f>Sheet1!$A$2:$A$13</c:f>
+              <c:f>Sheet1!$A$2:$A$15</c:f>
               <c:strCache>
-                <c:ptCount val="12"/>
+                <c:ptCount val="14"/>
                 <c:pt idx="0">
                   <c:v>2015</c:v>
                 </c:pt>
@@ -439,16 +463,22 @@
                 </c:pt>
                 <c:pt idx="11">
                   <c:v>2026</c:v>
+                </c:pt>
+                <c:pt idx="12">
+                  <c:v>CY27f</c:v>
+                </c:pt>
+                <c:pt idx="13">
+                  <c:v>CY28f</c:v>
                 </c:pt>
               </c:strCache>
             </c:strRef>
           </c:cat>
           <c:val>
             <c:numRef>
-              <c:f>Sheet1!$D$2:$D$13</c:f>
+              <c:f>Sheet1!$D$2:$D$15</c:f>
               <c:numCache>
                 <c:formatCode>"$"0</c:formatCode>
-                <c:ptCount val="12"/>
+                <c:ptCount val="14"/>
                 <c:pt idx="0">
                   <c:v>50</c:v>
                 </c:pt>
@@ -484,6 +514,12 @@
                 </c:pt>
                 <c:pt idx="11">
                   <c:v>87</c:v>
+                </c:pt>
+                <c:pt idx="12">
+                  <c:v>80</c:v>
+                </c:pt>
+                <c:pt idx="13">
+                  <c:v>92</c:v>
                 </c:pt>
               </c:numCache>
             </c:numRef>
@@ -516,9 +552,9 @@
           </c:marker>
           <c:cat>
             <c:strRef>
-              <c:f>Sheet1!$A$2:$A$13</c:f>
+              <c:f>Sheet1!$A$2:$A$15</c:f>
               <c:strCache>
-                <c:ptCount val="12"/>
+                <c:ptCount val="14"/>
                 <c:pt idx="0">
                   <c:v>2015</c:v>
                 </c:pt>
@@ -554,16 +590,22 @@
                 </c:pt>
                 <c:pt idx="11">
                   <c:v>2026</c:v>
+                </c:pt>
+                <c:pt idx="12">
+                  <c:v>CY27f</c:v>
+                </c:pt>
+                <c:pt idx="13">
+                  <c:v>CY28f</c:v>
                 </c:pt>
               </c:strCache>
             </c:strRef>
           </c:cat>
           <c:val>
             <c:numRef>
-              <c:f>Sheet1!$E$2:$E$13</c:f>
+              <c:f>Sheet1!$E$2:$E$15</c:f>
               <c:numCache>
                 <c:formatCode>"$"0</c:formatCode>
-                <c:ptCount val="12"/>
+                <c:ptCount val="14"/>
                 <c:pt idx="0">
                   <c:v>34</c:v>
                 </c:pt>
@@ -599,6 +641,12 @@
                 </c:pt>
                 <c:pt idx="11">
                   <c:v>49</c:v>
+                </c:pt>
+                <c:pt idx="12">
+                  <c:v>62</c:v>
+                </c:pt>
+                <c:pt idx="13">
+                  <c:v>71</c:v>
                 </c:pt>
               </c:numCache>
             </c:numRef>
@@ -631,9 +679,9 @@
           </c:marker>
           <c:cat>
             <c:strRef>
-              <c:f>Sheet1!$A$2:$A$13</c:f>
+              <c:f>Sheet1!$A$2:$A$15</c:f>
               <c:strCache>
-                <c:ptCount val="12"/>
+                <c:ptCount val="14"/>
                 <c:pt idx="0">
                   <c:v>2015</c:v>
                 </c:pt>
@@ -669,16 +717,22 @@
                 </c:pt>
                 <c:pt idx="11">
                   <c:v>2026</c:v>
+                </c:pt>
+                <c:pt idx="12">
+                  <c:v>CY27f</c:v>
+                </c:pt>
+                <c:pt idx="13">
+                  <c:v>CY28f</c:v>
                 </c:pt>
               </c:strCache>
             </c:strRef>
           </c:cat>
           <c:val>
             <c:numRef>
-              <c:f>Sheet1!$F$2:$F$13</c:f>
+              <c:f>Sheet1!$F$2:$F$15</c:f>
               <c:numCache>
                 <c:formatCode>"$"0</c:formatCode>
-                <c:ptCount val="12"/>
+                <c:ptCount val="14"/>
                 <c:pt idx="0">
                   <c:v>48</c:v>
                 </c:pt>
@@ -23786,7 +23840,7 @@
                 </a:solidFill>
                 <a:latin typeface="Calibri"/>
               </a:rPr>
-              <a:t>The long view — a decade of prices</a:t>
+              <a:t>The long view — a decade of prices, and the forward</a:t>
             </a:r>
           </a:p>
         </p:txBody>
@@ -23904,7 +23958,7 @@
                 </a:solidFill>
                 <a:latin typeface="Calibri"/>
               </a:rPr>
-              <a:t>Wholesale prices move in shock-driven cycles; 2022's gas shock towers over the decade, and today has eased.</a:t>
+              <a:t>2022's gas shock towers over the decade; the last two points (CY27–28f) are the ASX forward — low and flat.</a:t>
             </a:r>
           </a:p>
         </p:txBody>
@@ -24343,7 +24397,7 @@
                 </a:solidFill>
                 <a:latin typeface="Calibri"/>
               </a:rPr>
-              <a:t>21 GW of coal</a:t>
+              <a:t>ASX forward (CY27–28):</a:t>
             </a:r>
             <a:r>
               <a:rPr sz="1600" b="0">
@@ -24352,7 +24406,25 @@
                 </a:solidFill>
                 <a:latin typeface="Calibri"/>
               </a:rPr>
-              <a:t> still operating; ~6 GW exits 2028–29 (Yallourn, Eraring, Gladstone).</a:t>
+              <a:t> NSW ~$85, VIC ~$62–71 (cheapest), </a:t>
+            </a:r>
+            <a:r>
+              <a:rPr sz="1600" b="1">
+                <a:solidFill>
+                  <a:srgbClr val="111820"/>
+                </a:solidFill>
+                <a:latin typeface="Calibri"/>
+              </a:rPr>
+              <a:t>SA in contango to ~$92</a:t>
+            </a:r>
+            <a:r>
+              <a:rPr sz="1600" b="0">
+                <a:solidFill>
+                  <a:srgbClr val="37424F"/>
+                </a:solidFill>
+                <a:latin typeface="Calibri"/>
+              </a:rPr>
+              <a:t> — where projects hedge and lenders price risk.</a:t>
             </a:r>
           </a:p>
           <a:p>
@@ -24374,31 +24446,22 @@
               <a:t>▸  </a:t>
             </a:r>
             <a:r>
+              <a:rPr sz="1600" b="1">
+                <a:solidFill>
+                  <a:srgbClr val="111820"/>
+                </a:solidFill>
+                <a:latin typeface="Calibri"/>
+              </a:rPr>
+              <a:t>21 GW of coal</a:t>
+            </a:r>
+            <a:r>
               <a:rPr sz="1600" b="0">
                 <a:solidFill>
                   <a:srgbClr val="37424F"/>
                 </a:solidFill>
                 <a:latin typeface="Calibri"/>
               </a:rPr>
-              <a:t>Rule of thumb: </a:t>
-            </a:r>
-            <a:r>
-              <a:rPr sz="1600" b="1">
-                <a:solidFill>
-                  <a:srgbClr val="111820"/>
-                </a:solidFill>
-                <a:latin typeface="Calibri"/>
-              </a:rPr>
-              <a:t>+1 GW of average demand ≈ +$20/MWh</a:t>
-            </a:r>
-            <a:r>
-              <a:rPr sz="1600" b="0">
-                <a:solidFill>
-                  <a:srgbClr val="37424F"/>
-                </a:solidFill>
-                <a:latin typeface="Calibri"/>
-              </a:rPr>
-              <a:t> — convex into scarcity (6 GW→$64, 9 GW→$246).</a:t>
+              <a:t> still operating; ~6 GW exits 2028–29 (Yallourn, Eraring, Gladstone).</a:t>
             </a:r>
           </a:p>
           <a:p>
@@ -24535,7 +24598,7 @@
                 </a:solidFill>
                 <a:latin typeface="Calibri"/>
               </a:rPr>
-              <a:t>These are market outturns — but they re-rate the ~3–4 yr forward curve and the long-term forecasts that underwrite FID.</a:t>
+              <a:t>Today's outturns re-rate the forward curve above and the long-term forecasts that underwrite FID.</a:t>
             </a:r>
           </a:p>
         </p:txBody>

</xml_diff>

<commit_message>
Reading the NEM: explain why 2025 was the value-factor trough
Adds a data-backed reading block (kit) + deck notes: 2025 saw a record +2.8 GW
solar land before storage caught up, so midday negative-price frequency roughly
doubled (NSW 13->30%, QLD 39->53%); 2026 paused solar (+0.3 GW) while ~8 GW of
batteries soaked the midday trough, so capture recovered. Like-for-like Jan-Aug
window, so the direction is real (pool softening also flatters the ratio).

Co-Authored-By: Claude Opus 4.8 <noreply@anthropic.com>
</commit_message>
<xml_diff>
--- a/nem-team-day/Reading-the-NEM-Team-Day.pptx
+++ b/nem-team-day/Reading-the-NEM-Team-Day.pptx
@@ -15850,7 +15850,7 @@
                 </a:solidFill>
                 <a:latin typeface="Calibri"/>
               </a:rPr>
-              <a:t>The trough is a 2023–25 story in every mainland state — and 2026 YTD charges back: QLD 0.28→0.50, VIC 0.34→0.57, NSW 0.43→0.63, SA 0.53→0.67. (2026 YTD is winter-weighted, so read the direction.)</a:t>
+              <a:t>Why 2025 was the trough: +2.8 GW of solar (a record) landed before storage caught up, so midday negative-price frequency roughly doubled (NSW 13→30%, QLD 39→53%). In 2026 new solar paused (+0.3 GW) and ~8 GW of batteries began soaking the midday trough — so capture recovered everywhere (QLD 0.28→0.50, NSW 0.43→0.63). 2026 is YTD, so read the direction.</a:t>
             </a:r>
           </a:p>
         </p:txBody>
@@ -18286,6 +18286,79 @@
               <a:t>▸  </a:t>
             </a:r>
             <a:r>
+              <a:rPr sz="1600" b="1">
+                <a:solidFill>
+                  <a:srgbClr val="111820"/>
+                </a:solidFill>
+                <a:latin typeface="Calibri"/>
+              </a:rPr>
+              <a:t>Why 2025 was the trough:</a:t>
+            </a:r>
+            <a:r>
+              <a:rPr sz="1600" b="0">
+                <a:solidFill>
+                  <a:srgbClr val="37424F"/>
+                </a:solidFill>
+                <a:latin typeface="Calibri"/>
+              </a:rPr>
+              <a:t> a record </a:t>
+            </a:r>
+            <a:r>
+              <a:rPr sz="1600" b="1">
+                <a:solidFill>
+                  <a:srgbClr val="111820"/>
+                </a:solidFill>
+                <a:latin typeface="Calibri"/>
+              </a:rPr>
+              <a:t>+2.8 GW</a:t>
+            </a:r>
+            <a:r>
+              <a:rPr sz="1600" b="0">
+                <a:solidFill>
+                  <a:srgbClr val="37424F"/>
+                </a:solidFill>
+                <a:latin typeface="Calibri"/>
+              </a:rPr>
+              <a:t> solar landed before storage caught up — </a:t>
+            </a:r>
+            <a:r>
+              <a:rPr sz="1600" b="1">
+                <a:solidFill>
+                  <a:srgbClr val="111820"/>
+                </a:solidFill>
+                <a:latin typeface="Calibri"/>
+              </a:rPr>
+              <a:t>midday negatives ~doubled</a:t>
+            </a:r>
+            <a:r>
+              <a:rPr sz="1600" b="0">
+                <a:solidFill>
+                  <a:srgbClr val="37424F"/>
+                </a:solidFill>
+                <a:latin typeface="Calibri"/>
+              </a:rPr>
+              <a:t> (NSW 13→30%); 2026's battery wave (~8 GW) soaked it back.</a:t>
+            </a:r>
+          </a:p>
+          <a:p>
+            <a:pPr>
+              <a:lnSpc>
+                <a:spcPct val="105000"/>
+              </a:lnSpc>
+              <a:spcAft>
+                <a:spcPts val="1100"/>
+              </a:spcAft>
+            </a:pPr>
+            <a:r>
+              <a:rPr sz="1600" b="1">
+                <a:solidFill>
+                  <a:srgbClr val="B21E46"/>
+                </a:solidFill>
+                <a:latin typeface="Calibri"/>
+              </a:rPr>
+              <a:t>▸  </a:t>
+            </a:r>
+            <a:r>
               <a:rPr sz="1600" b="0">
                 <a:solidFill>
                   <a:srgbClr val="37424F"/>

</xml_diff>